<commit_message>
Hoan thien du an 10/10: Search, Import CSV, Unit Tests, PPTX 16:9, Inno Setup
</commit_message>
<xml_diff>
--- a/BaoCaoTienDo.pptx
+++ b/BaoCaoTienDo.pptx
@@ -10,9 +10,8 @@
     <p:sldId id="258" r:id="rId4"/>
     <p:sldId id="259" r:id="rId5"/>
     <p:sldId id="260" r:id="rId6"/>
-    <p:sldId id="263" r:id="rId7"/>
   </p:sldIdLst>
-  <p:sldSz cx="9144000" cy="6858000" type="screen4x3"/>
+  <p:sldSz cx="12192000" cy="6858000"/>
   <p:notesSz cx="6858000" cy="9144000"/>
   <p:defaultTextStyle>
     <a:defPPr>
@@ -307,7 +306,7 @@
           <a:p>
             <a:fld id="{5BCAD085-E8A6-8845-BD4E-CB4CCA059FC4}" type="datetimeFigureOut">
               <a:rPr lang="en-US" smtClean="0"/>
-              <a:t>5/12/2026</a:t>
+              <a:t>5/19/2026</a:t>
             </a:fld>
             <a:endParaRPr lang="en-US"/>
           </a:p>
@@ -475,7 +474,7 @@
           <a:p>
             <a:fld id="{5BCAD085-E8A6-8845-BD4E-CB4CCA059FC4}" type="datetimeFigureOut">
               <a:rPr lang="en-US" smtClean="0"/>
-              <a:t>5/12/2026</a:t>
+              <a:t>5/19/2026</a:t>
             </a:fld>
             <a:endParaRPr lang="en-US"/>
           </a:p>
@@ -653,7 +652,7 @@
           <a:p>
             <a:fld id="{5BCAD085-E8A6-8845-BD4E-CB4CCA059FC4}" type="datetimeFigureOut">
               <a:rPr lang="en-US" smtClean="0"/>
-              <a:t>5/12/2026</a:t>
+              <a:t>5/19/2026</a:t>
             </a:fld>
             <a:endParaRPr lang="en-US"/>
           </a:p>
@@ -821,7 +820,7 @@
           <a:p>
             <a:fld id="{5BCAD085-E8A6-8845-BD4E-CB4CCA059FC4}" type="datetimeFigureOut">
               <a:rPr lang="en-US" smtClean="0"/>
-              <a:t>5/12/2026</a:t>
+              <a:t>5/19/2026</a:t>
             </a:fld>
             <a:endParaRPr lang="en-US"/>
           </a:p>
@@ -1066,7 +1065,7 @@
           <a:p>
             <a:fld id="{5BCAD085-E8A6-8845-BD4E-CB4CCA059FC4}" type="datetimeFigureOut">
               <a:rPr lang="en-US" smtClean="0"/>
-              <a:t>5/12/2026</a:t>
+              <a:t>5/19/2026</a:t>
             </a:fld>
             <a:endParaRPr lang="en-US"/>
           </a:p>
@@ -1351,7 +1350,7 @@
           <a:p>
             <a:fld id="{5BCAD085-E8A6-8845-BD4E-CB4CCA059FC4}" type="datetimeFigureOut">
               <a:rPr lang="en-US" smtClean="0"/>
-              <a:t>5/12/2026</a:t>
+              <a:t>5/19/2026</a:t>
             </a:fld>
             <a:endParaRPr lang="en-US"/>
           </a:p>
@@ -1770,7 +1769,7 @@
           <a:p>
             <a:fld id="{5BCAD085-E8A6-8845-BD4E-CB4CCA059FC4}" type="datetimeFigureOut">
               <a:rPr lang="en-US" smtClean="0"/>
-              <a:t>5/12/2026</a:t>
+              <a:t>5/19/2026</a:t>
             </a:fld>
             <a:endParaRPr lang="en-US"/>
           </a:p>
@@ -1887,7 +1886,7 @@
           <a:p>
             <a:fld id="{5BCAD085-E8A6-8845-BD4E-CB4CCA059FC4}" type="datetimeFigureOut">
               <a:rPr lang="en-US" smtClean="0"/>
-              <a:t>5/12/2026</a:t>
+              <a:t>5/19/2026</a:t>
             </a:fld>
             <a:endParaRPr lang="en-US"/>
           </a:p>
@@ -1982,7 +1981,7 @@
           <a:p>
             <a:fld id="{5BCAD085-E8A6-8845-BD4E-CB4CCA059FC4}" type="datetimeFigureOut">
               <a:rPr lang="en-US" smtClean="0"/>
-              <a:t>5/12/2026</a:t>
+              <a:t>5/19/2026</a:t>
             </a:fld>
             <a:endParaRPr lang="en-US"/>
           </a:p>
@@ -2257,7 +2256,7 @@
           <a:p>
             <a:fld id="{5BCAD085-E8A6-8845-BD4E-CB4CCA059FC4}" type="datetimeFigureOut">
               <a:rPr lang="en-US" smtClean="0"/>
-              <a:t>5/12/2026</a:t>
+              <a:t>5/19/2026</a:t>
             </a:fld>
             <a:endParaRPr lang="en-US"/>
           </a:p>
@@ -2509,7 +2508,7 @@
           <a:p>
             <a:fld id="{5BCAD085-E8A6-8845-BD4E-CB4CCA059FC4}" type="datetimeFigureOut">
               <a:rPr lang="en-US" smtClean="0"/>
-              <a:t>5/12/2026</a:t>
+              <a:t>5/19/2026</a:t>
             </a:fld>
             <a:endParaRPr lang="en-US"/>
           </a:p>
@@ -2720,7 +2719,7 @@
           <a:p>
             <a:fld id="{5BCAD085-E8A6-8845-BD4E-CB4CCA059FC4}" type="datetimeFigureOut">
               <a:rPr lang="en-US" smtClean="0"/>
-              <a:t>5/12/2026</a:t>
+              <a:t>5/19/2026</a:t>
             </a:fld>
             <a:endParaRPr lang="en-US"/>
           </a:p>
@@ -3081,6 +3080,14 @@
 <file path=ppt/slides/slide1.xml><?xml version="1.0" encoding="utf-8"?>
 <p:sld xmlns:a="http://schemas.openxmlformats.org/drawingml/2006/main" xmlns:r="http://schemas.openxmlformats.org/officeDocument/2006/relationships" xmlns:p="http://schemas.openxmlformats.org/presentationml/2006/main">
   <p:cSld>
+    <p:bg>
+      <p:bgPr>
+        <a:solidFill>
+          <a:srgbClr val="1E1E24"/>
+        </a:solidFill>
+        <a:effectLst/>
+      </p:bgPr>
+    </p:bg>
     <p:spTree>
       <p:nvGrpSpPr>
         <p:cNvPr id="1" name=""/>
@@ -3105,19 +3112,67 @@
             <p:ph type="ctrTitle"/>
           </p:nvPr>
         </p:nvSpPr>
-        <p:spPr/>
-        <p:txBody>
-          <a:bodyPr/>
-          <a:lstStyle/>
-          <a:p>
-            <a:r>
-              <a:t>BÁO CÁO TIẾN ĐỘ DỰ ÁN</a:t>
-            </a:r>
-          </a:p>
-          <a:p>
-            <a:r>
+        <p:spPr>
+          <a:xfrm>
+            <a:off x="2339939" y="1958975"/>
+            <a:ext cx="7772400" cy="1470025"/>
+          </a:xfrm>
+        </p:spPr>
+        <p:txBody>
+          <a:bodyPr>
+            <a:normAutofit fontScale="90000"/>
+          </a:bodyPr>
+          <a:lstStyle/>
+          <a:p>
+            <a:r>
+              <a:rPr sz="3600" b="1">
+                <a:solidFill>
+                  <a:srgbClr val="00FFCC"/>
+                </a:solidFill>
+                <a:latin typeface="Arial"/>
+              </a:rPr>
+              <a:t>BÁO CÁO TIẾN ĐỘ DỰ ÁN </a:t>
+            </a:r>
+            <a:br>
+              <a:rPr lang="en-US" sz="3600" b="1">
+                <a:solidFill>
+                  <a:srgbClr val="00FFCC"/>
+                </a:solidFill>
+                <a:latin typeface="Arial"/>
+              </a:rPr>
+            </a:br>
+            <a:r>
+              <a:rPr sz="3600" b="1">
+                <a:solidFill>
+                  <a:srgbClr val="00FFCC"/>
+                </a:solidFill>
+                <a:latin typeface="Arial"/>
+              </a:rPr>
               <a:t>Real-time Currency Tracker Pro</a:t>
             </a:r>
+            <a:br>
+              <a:rPr lang="en-US" sz="3600" b="1">
+                <a:solidFill>
+                  <a:srgbClr val="00FFCC"/>
+                </a:solidFill>
+                <a:latin typeface="Arial"/>
+              </a:rPr>
+            </a:br>
+            <a:r>
+              <a:rPr lang="en-US" sz="3600" b="1">
+                <a:solidFill>
+                  <a:srgbClr val="00FFCC"/>
+                </a:solidFill>
+                <a:latin typeface="Arial"/>
+              </a:rPr>
+              <a:t>(Theo dõi tỉ giá tiền tệ)</a:t>
+            </a:r>
+            <a:endParaRPr sz="3600" b="1">
+              <a:solidFill>
+                <a:srgbClr val="00FFCC"/>
+              </a:solidFill>
+              <a:latin typeface="Arial"/>
+            </a:endParaRPr>
           </a:p>
         </p:txBody>
       </p:sp>
@@ -3131,18 +3186,55 @@
             <p:ph type="subTitle" idx="1"/>
           </p:nvPr>
         </p:nvSpPr>
-        <p:spPr/>
-        <p:txBody>
-          <a:bodyPr/>
-          <a:lstStyle/>
-          <a:p>
-            <a:r>
-              <a:t>Môn học: Lập trình Python</a:t>
-            </a:r>
-          </a:p>
-          <a:p>
-            <a:r>
-              <a:t>Thực hiện: Nhóm 2</a:t>
+        <p:spPr>
+          <a:xfrm>
+            <a:off x="3025739" y="3878494"/>
+            <a:ext cx="6400800" cy="1752600"/>
+          </a:xfrm>
+        </p:spPr>
+        <p:txBody>
+          <a:bodyPr/>
+          <a:lstStyle/>
+          <a:p>
+            <a:r>
+              <a:rPr sz="1400">
+                <a:solidFill>
+                  <a:srgbClr val="A0A0A0"/>
+                </a:solidFill>
+                <a:latin typeface="Arial"/>
+              </a:rPr>
+              <a:t>Thực hiện: Nhóm 2 - Lớp Lập trình Python</a:t>
+            </a:r>
+          </a:p>
+          <a:p>
+            <a:r>
+              <a:rPr sz="1400">
+                <a:solidFill>
+                  <a:srgbClr val="A0A0A0"/>
+                </a:solidFill>
+                <a:latin typeface="Arial"/>
+              </a:rPr>
+              <a:t>Báo cáo tiến độ Tuần </a:t>
+            </a:r>
+            <a:r>
+              <a:rPr lang="en-US" sz="1400">
+                <a:solidFill>
+                  <a:srgbClr val="A0A0A0"/>
+                </a:solidFill>
+                <a:latin typeface="Arial"/>
+              </a:rPr>
+              <a:t>2</a:t>
+            </a:r>
+          </a:p>
+          <a:p>
+            <a:r>
+              <a:rPr sz="1400">
+                <a:solidFill>
+                  <a:srgbClr val="A0A0A0"/>
+                </a:solidFill>
+                <a:latin typeface="Arial"/>
+              </a:rPr>
+              <a:t>Giảng viên hướng dẫn: Vũ Duy Sơn</a:t>
             </a:r>
           </a:p>
         </p:txBody>
@@ -3158,6 +3250,14 @@
 <file path=ppt/slides/slide2.xml><?xml version="1.0" encoding="utf-8"?>
 <p:sld xmlns:a="http://schemas.openxmlformats.org/drawingml/2006/main" xmlns:r="http://schemas.openxmlformats.org/officeDocument/2006/relationships" xmlns:p="http://schemas.openxmlformats.org/presentationml/2006/main">
   <p:cSld>
+    <p:bg>
+      <p:bgPr>
+        <a:solidFill>
+          <a:srgbClr val="1E1E24"/>
+        </a:solidFill>
+        <a:effectLst/>
+      </p:bgPr>
+    </p:bg>
     <p:spTree>
       <p:nvGrpSpPr>
         <p:cNvPr id="1" name=""/>
@@ -3182,13 +3282,25 @@
             <p:ph type="title"/>
           </p:nvPr>
         </p:nvSpPr>
-        <p:spPr/>
-        <p:txBody>
-          <a:bodyPr/>
-          <a:lstStyle/>
-          <a:p>
-            <a:r>
-              <a:t>1. Mục tiêu dự án</a:t>
+        <p:spPr>
+          <a:xfrm>
+            <a:off x="1535987" y="274638"/>
+            <a:ext cx="8229600" cy="1143000"/>
+          </a:xfrm>
+        </p:spPr>
+        <p:txBody>
+          <a:bodyPr/>
+          <a:lstStyle/>
+          <a:p>
+            <a:pPr algn="l"/>
+            <a:r>
+              <a:rPr sz="2800" b="1">
+                <a:solidFill>
+                  <a:srgbClr val="00FFCC"/>
+                </a:solidFill>
+                <a:latin typeface="Arial"/>
+              </a:rPr>
+              <a:t>1. Đã làm được gì? (Kiến trúc &amp; CSDL SQLite)</a:t>
             </a:r>
           </a:p>
         </p:txBody>
@@ -3203,18 +3315,61 @@
             <p:ph idx="1"/>
           </p:nvPr>
         </p:nvSpPr>
-        <p:spPr/>
-        <p:txBody>
-          <a:bodyPr/>
-          <a:lstStyle/>
-          <a:p>
-            <a:r>
-              <a:t>Xây dựng ứng dụng Desktop bằng Python giúp theo dõi tỷ giá ngoại tệ trực tuyến.</a:t>
-            </a:r>
-          </a:p>
-          <a:p>
-            <a:r>
-              <a:t>Tuân thủ chặt chẽ mô hình thiết kế phần mềm MVC (Model - View - Controller).</a:t>
+        <p:spPr>
+          <a:xfrm>
+            <a:off x="1535987" y="1497458"/>
+            <a:ext cx="8229600" cy="4525963"/>
+          </a:xfrm>
+        </p:spPr>
+        <p:txBody>
+          <a:bodyPr wrap="square"/>
+          <a:lstStyle/>
+          <a:p>
+            <a:pPr>
+              <a:spcAft>
+                <a:spcPts val="1200"/>
+              </a:spcAft>
+            </a:pPr>
+            <a:r>
+              <a:rPr sz="1700">
+                <a:solidFill>
+                  <a:srgbClr val="F0F0F0"/>
+                </a:solidFill>
+                <a:latin typeface="Arial"/>
+              </a:rPr>
+              <a:t>Hoàn thiện mô hình kiến trúc MVC phân cấp chuẩn mực: Model (SQLite &amp; Pandas), View (CustomTkinter), Controller (AppController) và Service chạy ngầm (APIService).</a:t>
+            </a:r>
+          </a:p>
+          <a:p>
+            <a:pPr>
+              <a:spcAft>
+                <a:spcPts val="1200"/>
+              </a:spcAft>
+            </a:pPr>
+            <a:r>
+              <a:rPr sz="1700">
+                <a:solidFill>
+                  <a:srgbClr val="F0F0F0"/>
+                </a:solidFill>
+                <a:latin typeface="Arial"/>
+              </a:rPr>
+              <a:t>Phân tích dữ liệu bằng Pandas &amp; Numpy: Viết các hàm phân tích lấy lịch sử tỷ giá từ SQLite và tính toán động các chỉ số thống kê tài chính (Mean, Min, Max, Volatility).</a:t>
+            </a:r>
+          </a:p>
+          <a:p>
+            <a:pPr>
+              <a:spcAft>
+                <a:spcPts val="1200"/>
+              </a:spcAft>
+            </a:pPr>
+            <a:r>
+              <a:rPr sz="1700">
+                <a:solidFill>
+                  <a:srgbClr val="F0F0F0"/>
+                </a:solidFill>
+                <a:latin typeface="Arial"/>
+              </a:rPr>
+              <a:t>Viết thành công bộ kiểm thử tự động (Unit Tests) trong tests/test_database.py xác minh tính chính xác của các thuật toán tính toán thống kê dữ liệu.</a:t>
             </a:r>
           </a:p>
         </p:txBody>
@@ -3230,6 +3385,14 @@
 <file path=ppt/slides/slide3.xml><?xml version="1.0" encoding="utf-8"?>
 <p:sld xmlns:a="http://schemas.openxmlformats.org/drawingml/2006/main" xmlns:r="http://schemas.openxmlformats.org/officeDocument/2006/relationships" xmlns:p="http://schemas.openxmlformats.org/presentationml/2006/main">
   <p:cSld>
+    <p:bg>
+      <p:bgPr>
+        <a:solidFill>
+          <a:srgbClr val="1E1E24"/>
+        </a:solidFill>
+        <a:effectLst/>
+      </p:bgPr>
+    </p:bg>
     <p:spTree>
       <p:nvGrpSpPr>
         <p:cNvPr id="1" name=""/>
@@ -3254,13 +3417,25 @@
             <p:ph type="title"/>
           </p:nvPr>
         </p:nvSpPr>
-        <p:spPr/>
-        <p:txBody>
-          <a:bodyPr/>
-          <a:lstStyle/>
-          <a:p>
-            <a:r>
-              <a:t>2. Đã làm được gì? (Tổng quan)</a:t>
+        <p:spPr>
+          <a:xfrm>
+            <a:off x="1125019" y="171897"/>
+            <a:ext cx="8229600" cy="1143000"/>
+          </a:xfrm>
+        </p:spPr>
+        <p:txBody>
+          <a:bodyPr/>
+          <a:lstStyle/>
+          <a:p>
+            <a:pPr algn="l"/>
+            <a:r>
+              <a:rPr sz="2800" b="1">
+                <a:solidFill>
+                  <a:srgbClr val="00FFCC"/>
+                </a:solidFill>
+                <a:latin typeface="Arial"/>
+              </a:rPr>
+              <a:t>1. Đã làm được gì? (Giao diện &amp; Tính năng Nâng cao)</a:t>
             </a:r>
           </a:p>
         </p:txBody>
@@ -3275,36 +3450,113 @@
             <p:ph idx="1"/>
           </p:nvPr>
         </p:nvSpPr>
-        <p:spPr/>
-        <p:txBody>
-          <a:bodyPr/>
-          <a:lstStyle/>
-          <a:p>
-            <a:r>
-              <a:t>Xây dựng xong bộ khung ứng dụng.</a:t>
-            </a:r>
-          </a:p>
-          <a:p>
-            <a:r>
-              <a:rPr lang="en-US"/>
-              <a:t>Hoàn thiện cấu trúc </a:t>
-            </a:r>
-            <a:r>
-              <a:t>MVC: Phân tách rõ ràng Model, View, Controller.</a:t>
-            </a:r>
-          </a:p>
-          <a:p>
-            <a:r>
-              <a:t>Tích hợp SQLite để lưu trữ lịch sử tỷ giá vĩnh viễn</a:t>
-            </a:r>
-            <a:r>
-              <a:rPr lang="en-US"/>
-              <a:t>, có Background Thread tự động (lấy) dữ liệu mỗi 30 giây (real-time)</a:t>
-            </a:r>
-            <a:endParaRPr/>
-          </a:p>
-        </p:txBody>
-      </p:sp>
+        <p:spPr>
+          <a:xfrm>
+            <a:off x="1125019" y="1486793"/>
+            <a:ext cx="8229600" cy="4525963"/>
+          </a:xfrm>
+        </p:spPr>
+        <p:txBody>
+          <a:bodyPr wrap="square"/>
+          <a:lstStyle/>
+          <a:p>
+            <a:pPr>
+              <a:spcAft>
+                <a:spcPts val="1200"/>
+              </a:spcAft>
+            </a:pPr>
+            <a:r>
+              <a:rPr sz="1700">
+                <a:solidFill>
+                  <a:srgbClr val="F0F0F0"/>
+                </a:solidFill>
+                <a:latin typeface="Arial"/>
+              </a:rPr>
+              <a:t>Tương tác API bất đồng bộ: Gọi ExchangeRate-API định kỳ mỗi </a:t>
+            </a:r>
+            <a:r>
+              <a:rPr lang="en-US" sz="1700">
+                <a:solidFill>
+                  <a:srgbClr val="F0F0F0"/>
+                </a:solidFill>
+                <a:latin typeface="Arial"/>
+              </a:rPr>
+              <a:t>1 tiếng </a:t>
+            </a:r>
+            <a:r>
+              <a:rPr sz="1700">
+                <a:solidFill>
+                  <a:srgbClr val="F0F0F0"/>
+                </a:solidFill>
+                <a:latin typeface="Arial"/>
+              </a:rPr>
+              <a:t>để cập nhật tỷ giá ngoại tệ thực tế trực tuyến trên thế giới.</a:t>
+            </a:r>
+          </a:p>
+          <a:p>
+            <a:pPr>
+              <a:spcAft>
+                <a:spcPts val="1200"/>
+              </a:spcAft>
+            </a:pPr>
+            <a:r>
+              <a:rPr sz="1700">
+                <a:solidFill>
+                  <a:srgbClr val="F0F0F0"/>
+                </a:solidFill>
+                <a:latin typeface="Arial"/>
+              </a:rPr>
+              <a:t>Vẽ đồ thị Matplotlib: Tích hợp cửa sổ biểu đồ (ChartWindow) nhúng trực tiếp Matplotlib vẽ biểu đồ đường mô tả lịch sử tỷ giá trực quan.</a:t>
+            </a:r>
+          </a:p>
+          <a:p>
+            <a:pPr>
+              <a:spcAft>
+                <a:spcPts val="1200"/>
+              </a:spcAft>
+            </a:pPr>
+            <a:r>
+              <a:rPr sz="1700">
+                <a:solidFill>
+                  <a:srgbClr val="F0F0F0"/>
+                </a:solidFill>
+                <a:latin typeface="Arial"/>
+              </a:rPr>
+              <a:t>Màn hình chờ &amp; Mở hướng dẫn sử dụng: Thiết lập Splash Screen có thanh tiến trình khởi chạy và bổ sung nút mở tài liệu hướng dẫn định dạng hệ thống.</a:t>
+            </a:r>
+          </a:p>
+        </p:txBody>
+      </p:sp>
+      <p:pic>
+        <p:nvPicPr>
+          <p:cNvPr id="5" name="Picture 4">
+            <a:extLst>
+              <a:ext uri="{FF2B5EF4-FFF2-40B4-BE49-F238E27FC236}">
+                <a16:creationId xmlns:a16="http://schemas.microsoft.com/office/drawing/2014/main" id="{4960D309-071F-C1F0-2350-1373BDE3A772}"/>
+              </a:ext>
+            </a:extLst>
+          </p:cNvPr>
+          <p:cNvPicPr>
+            <a:picLocks noChangeAspect="1"/>
+          </p:cNvPicPr>
+          <p:nvPr/>
+        </p:nvPicPr>
+        <p:blipFill>
+          <a:blip r:embed="rId2"/>
+          <a:stretch>
+            <a:fillRect/>
+          </a:stretch>
+        </p:blipFill>
+        <p:spPr>
+          <a:xfrm>
+            <a:off x="2147298" y="3655227"/>
+            <a:ext cx="5024063" cy="2928135"/>
+          </a:xfrm>
+          <a:prstGeom prst="rect">
+            <a:avLst/>
+          </a:prstGeom>
+        </p:spPr>
+      </p:pic>
     </p:spTree>
   </p:cSld>
   <p:clrMapOvr>
@@ -3316,6 +3568,14 @@
 <file path=ppt/slides/slide4.xml><?xml version="1.0" encoding="utf-8"?>
 <p:sld xmlns:a="http://schemas.openxmlformats.org/drawingml/2006/main" xmlns:r="http://schemas.openxmlformats.org/officeDocument/2006/relationships" xmlns:p="http://schemas.openxmlformats.org/presentationml/2006/main">
   <p:cSld>
+    <p:bg>
+      <p:bgPr>
+        <a:solidFill>
+          <a:srgbClr val="1E1E24"/>
+        </a:solidFill>
+        <a:effectLst/>
+      </p:bgPr>
+    </p:bg>
     <p:spTree>
       <p:nvGrpSpPr>
         <p:cNvPr id="1" name=""/>
@@ -3340,13 +3600,25 @@
             <p:ph type="title"/>
           </p:nvPr>
         </p:nvSpPr>
-        <p:spPr/>
-        <p:txBody>
-          <a:bodyPr/>
-          <a:lstStyle/>
-          <a:p>
-            <a:r>
-              <a:t>3. Đã làm được gì? (Tính năng)</a:t>
+        <p:spPr>
+          <a:xfrm>
+            <a:off x="1577083" y="415712"/>
+            <a:ext cx="8229600" cy="1143000"/>
+          </a:xfrm>
+        </p:spPr>
+        <p:txBody>
+          <a:bodyPr/>
+          <a:lstStyle/>
+          <a:p>
+            <a:pPr algn="l"/>
+            <a:r>
+              <a:rPr sz="2800" b="1">
+                <a:solidFill>
+                  <a:srgbClr val="00FFCC"/>
+                </a:solidFill>
+                <a:latin typeface="Arial"/>
+              </a:rPr>
+              <a:t>2. Gặp khó khăn gì &amp; Cách khắc phục</a:t>
             </a:r>
           </a:p>
         </p:txBody>
@@ -3361,32 +3633,72 @@
             <p:ph idx="1"/>
           </p:nvPr>
         </p:nvSpPr>
-        <p:spPr/>
-        <p:txBody>
-          <a:bodyPr/>
-          <a:lstStyle/>
-          <a:p>
-            <a:r>
-              <a:t>Thiết kế giao diện Dark Mode chuyên nghiệp, thân thiện.</a:t>
-            </a:r>
-          </a:p>
-          <a:p>
-            <a:r>
-              <a:t>Quản lý danh sách các mã ngoại tệ chuẩn ISO (Thêm/Sửa/Xóa).</a:t>
-            </a:r>
-          </a:p>
-          <a:p>
-            <a:r>
-              <a:t>Tích hợp Pandas tính: Giá trung bình, cao nhất, thấp nhất và biến động.</a:t>
-            </a:r>
-          </a:p>
-          <a:p>
-            <a:r>
-              <a:t>Đóng gói phần mềm ra file .exe chạy độc lập.</a:t>
-            </a:r>
-          </a:p>
-        </p:txBody>
-      </p:sp>
+        <p:spPr>
+          <a:xfrm>
+            <a:off x="1577083" y="1713216"/>
+            <a:ext cx="8229600" cy="4525963"/>
+          </a:xfrm>
+        </p:spPr>
+        <p:txBody>
+          <a:bodyPr wrap="square"/>
+          <a:lstStyle/>
+          <a:p>
+            <a:pPr>
+              <a:spcAft>
+                <a:spcPts val="1200"/>
+              </a:spcAft>
+            </a:pPr>
+            <a:r>
+              <a:rPr sz="1700">
+                <a:solidFill>
+                  <a:srgbClr val="F0F0F0"/>
+                </a:solidFill>
+                <a:latin typeface="Arial"/>
+              </a:rPr>
+              <a:t>Khó khăn (Treo đơ giao diện - UI Freeze): Khi gửi HTTP GET Request tới REST API trên luồng chính, giao diện chính bị đơ trong vài giây.</a:t>
+            </a:r>
+            <a:br>
+              <a:rPr/>
+            </a:br>
+            <a:endParaRPr sz="1700">
+              <a:solidFill>
+                <a:srgbClr val="F0F0F0"/>
+              </a:solidFill>
+              <a:latin typeface="Arial"/>
+            </a:endParaRPr>
+          </a:p>
+        </p:txBody>
+      </p:sp>
+      <p:pic>
+        <p:nvPicPr>
+          <p:cNvPr id="5" name="Picture 4">
+            <a:extLst>
+              <a:ext uri="{FF2B5EF4-FFF2-40B4-BE49-F238E27FC236}">
+                <a16:creationId xmlns:a16="http://schemas.microsoft.com/office/drawing/2014/main" id="{1CE92268-F839-0699-67EC-0BE1CED74AEF}"/>
+              </a:ext>
+            </a:extLst>
+          </p:cNvPr>
+          <p:cNvPicPr>
+            <a:picLocks noChangeAspect="1"/>
+          </p:cNvPicPr>
+          <p:nvPr/>
+        </p:nvPicPr>
+        <p:blipFill>
+          <a:blip r:embed="rId2"/>
+          <a:stretch>
+            <a:fillRect/>
+          </a:stretch>
+        </p:blipFill>
+        <p:spPr>
+          <a:xfrm>
+            <a:off x="1577083" y="2838042"/>
+            <a:ext cx="8229600" cy="3401137"/>
+          </a:xfrm>
+          <a:prstGeom prst="rect">
+            <a:avLst/>
+          </a:prstGeom>
+        </p:spPr>
+      </p:pic>
     </p:spTree>
   </p:cSld>
   <p:clrMapOvr>
@@ -3398,6 +3710,14 @@
 <file path=ppt/slides/slide5.xml><?xml version="1.0" encoding="utf-8"?>
 <p:sld xmlns:a="http://schemas.openxmlformats.org/drawingml/2006/main" xmlns:r="http://schemas.openxmlformats.org/officeDocument/2006/relationships" xmlns:p="http://schemas.openxmlformats.org/presentationml/2006/main">
   <p:cSld>
+    <p:bg>
+      <p:bgPr>
+        <a:solidFill>
+          <a:srgbClr val="1E1E24"/>
+        </a:solidFill>
+        <a:effectLst/>
+      </p:bgPr>
+    </p:bg>
     <p:spTree>
       <p:nvGrpSpPr>
         <p:cNvPr id="1" name=""/>
@@ -3424,18 +3744,23 @@
         </p:nvSpPr>
         <p:spPr>
           <a:xfrm>
-            <a:off x="457200" y="274638"/>
-            <a:ext cx="8229600" cy="670584"/>
+            <a:off x="1464068" y="274638"/>
+            <a:ext cx="8229600" cy="1143000"/>
           </a:xfrm>
         </p:spPr>
         <p:txBody>
-          <a:bodyPr>
-            <a:normAutofit fontScale="90000"/>
-          </a:bodyPr>
-          <a:lstStyle/>
-          <a:p>
-            <a:r>
-              <a:t>4. Khó khăn gặp phải (Kỹ thuật)</a:t>
+          <a:bodyPr/>
+          <a:lstStyle/>
+          <a:p>
+            <a:pPr algn="l"/>
+            <a:r>
+              <a:rPr sz="2800" b="1">
+                <a:solidFill>
+                  <a:srgbClr val="00FFCC"/>
+                </a:solidFill>
+                <a:latin typeface="Arial"/>
+              </a:rPr>
+              <a:t>3. Dự kiến tuần sau làm gì? </a:t>
             </a:r>
           </a:p>
         </p:txBody>
@@ -3452,118 +3777,91 @@
         </p:nvSpPr>
         <p:spPr>
           <a:xfrm>
-            <a:off x="457200" y="1746606"/>
-            <a:ext cx="8229600" cy="4911047"/>
+            <a:off x="1464068" y="1628454"/>
+            <a:ext cx="8229600" cy="4525963"/>
           </a:xfrm>
         </p:spPr>
         <p:txBody>
-          <a:bodyPr>
-            <a:normAutofit/>
-          </a:bodyPr>
-          <a:lstStyle/>
-          <a:p>
-            <a:r>
-              <a:t>Khó khăn: </a:t>
-            </a:r>
-            <a:r>
-              <a:rPr lang="vi-VN"/>
-              <a:t>điểm yếu về mặt trải nghiệm người dùng (UX). Khi thêm cặp tiền tệ, người dùng đang phải nhớ và gõ tay mã ISO 3 ký tự (như USD, VND).</a:t>
-            </a:r>
-            <a:endParaRPr lang="en-US"/>
-          </a:p>
-          <a:p>
-            <a:r>
-              <a:rPr lang="vi-VN"/>
-              <a:t>Khắc phục:</a:t>
-            </a:r>
-            <a:r>
-              <a:rPr lang="en-US"/>
-              <a:t>-thay thế cái ô nhập liệu (TextBox) thành một hộp thả xuống DropdownList hiện thị các đơn vị tiền tệ </a:t>
-            </a:r>
-          </a:p>
-          <a:p>
-            <a:endParaRPr lang="vi-VN"/>
-          </a:p>
-        </p:txBody>
-      </p:sp>
-    </p:spTree>
-  </p:cSld>
-  <p:clrMapOvr>
-    <a:masterClrMapping/>
-  </p:clrMapOvr>
-</p:sld>
-</file>
-
-<file path=ppt/slides/slide6.xml><?xml version="1.0" encoding="utf-8"?>
-<p:sld xmlns:a="http://schemas.openxmlformats.org/drawingml/2006/main" xmlns:r="http://schemas.openxmlformats.org/officeDocument/2006/relationships" xmlns:p="http://schemas.openxmlformats.org/presentationml/2006/main">
-  <p:cSld>
-    <p:spTree>
-      <p:nvGrpSpPr>
-        <p:cNvPr id="1" name=""/>
-        <p:cNvGrpSpPr/>
-        <p:nvPr/>
-      </p:nvGrpSpPr>
-      <p:grpSpPr>
-        <a:xfrm>
-          <a:off x="0" y="0"/>
-          <a:ext cx="0" cy="0"/>
-          <a:chOff x="0" y="0"/>
-          <a:chExt cx="0" cy="0"/>
-        </a:xfrm>
-      </p:grpSpPr>
-      <p:sp>
-        <p:nvSpPr>
-          <p:cNvPr id="2" name="Title 1"/>
-          <p:cNvSpPr>
-            <a:spLocks noGrp="1"/>
-          </p:cNvSpPr>
-          <p:nvPr>
-            <p:ph type="title"/>
-          </p:nvPr>
-        </p:nvSpPr>
-        <p:spPr/>
-        <p:txBody>
-          <a:bodyPr/>
-          <a:lstStyle/>
-          <a:p>
-            <a:r>
-              <a:rPr lang="en-US"/>
-              <a:t>5</a:t>
-            </a:r>
-            <a:r>
-              <a:t>. Kế hoạch tiếp theo (Mở rộng)</a:t>
-            </a:r>
-          </a:p>
-        </p:txBody>
-      </p:sp>
-      <p:sp>
-        <p:nvSpPr>
-          <p:cNvPr id="3" name="Content Placeholder 2"/>
-          <p:cNvSpPr>
-            <a:spLocks noGrp="1"/>
-          </p:cNvSpPr>
-          <p:nvPr>
-            <p:ph idx="1"/>
-          </p:nvPr>
-        </p:nvSpPr>
-        <p:spPr/>
-        <p:txBody>
-          <a:bodyPr/>
-          <a:lstStyle/>
-          <a:p>
-            <a:r>
-              <a:t>Mini-Calculator: Thêm công cụ máy tính nhỏ ở Sidebar để người dùng nhập số tiền và đổi trực tiếp theo tỷ giá thực.</a:t>
-            </a:r>
-            <a:endParaRPr lang="en-US"/>
-          </a:p>
-          <a:p>
-            <a:r>
-              <a:rPr lang="vi-VN"/>
-              <a:t>Bổ sung hiệu ứng chuyển động mượt mà hơn.</a:t>
-            </a:r>
-          </a:p>
-          <a:p>
-            <a:endParaRPr/>
+          <a:bodyPr wrap="square"/>
+          <a:lstStyle/>
+          <a:p>
+            <a:pPr>
+              <a:spcAft>
+                <a:spcPts val="1200"/>
+              </a:spcAft>
+            </a:pPr>
+            <a:r>
+              <a:rPr sz="1700">
+                <a:solidFill>
+                  <a:srgbClr val="F0F0F0"/>
+                </a:solidFill>
+                <a:latin typeface="Arial"/>
+              </a:rPr>
+              <a:t>Tối ưu hiệu năng biểu đồ Matplotlib: Giới hạn số lượng điểm vẽ lịch sử tỷ giá tải lên biểu đồ nhằm kiểm soát tốt mức tiêu thụ RAM khi treo máy lâu ngày.</a:t>
+            </a:r>
+          </a:p>
+          <a:p>
+            <a:pPr>
+              <a:spcAft>
+                <a:spcPts val="1200"/>
+              </a:spcAft>
+            </a:pPr>
+            <a:r>
+              <a:rPr lang="en-US" sz="1700">
+                <a:solidFill>
+                  <a:srgbClr val="F0F0F0"/>
+                </a:solidFill>
+                <a:latin typeface="Arial"/>
+              </a:rPr>
+              <a:t>Thêm t</a:t>
+            </a:r>
+            <a:r>
+              <a:rPr sz="1700">
+                <a:solidFill>
+                  <a:srgbClr val="F0F0F0"/>
+                </a:solidFill>
+                <a:latin typeface="Arial"/>
+              </a:rPr>
+              <a:t>ính năng Cảnh báo tỷ giá thông minh (Price Alert): Tự động thay đổi màu chữ hiển thị (Cam/Đỏ) trên bảng khi tỷ giá vượt ngưỡng quy định trước</a:t>
+            </a:r>
+            <a:r>
+              <a:rPr lang="en-US" sz="1700">
+                <a:solidFill>
+                  <a:srgbClr val="F0F0F0"/>
+                </a:solidFill>
+                <a:latin typeface="Arial"/>
+              </a:rPr>
+              <a:t> (sử dụng màu chữ </a:t>
+            </a:r>
+            <a:r>
+              <a:rPr lang="en-US" sz="1700">
+                <a:solidFill>
+                  <a:srgbClr val="F0F0F0"/>
+                </a:solidFill>
+                <a:latin typeface="Arial"/>
+                <a:sym typeface="Wingdings" panose="05000000000000000000" pitchFamily="2" charset="2"/>
+              </a:rPr>
+              <a:t> đánh giá )</a:t>
+            </a:r>
+            <a:endParaRPr sz="1700">
+              <a:solidFill>
+                <a:srgbClr val="F0F0F0"/>
+              </a:solidFill>
+              <a:latin typeface="Arial"/>
+            </a:endParaRPr>
+          </a:p>
+          <a:p>
+            <a:pPr>
+              <a:spcAft>
+                <a:spcPts val="1200"/>
+              </a:spcAft>
+            </a:pPr>
+            <a:endParaRPr sz="1700">
+              <a:solidFill>
+                <a:srgbClr val="F0F0F0"/>
+              </a:solidFill>
+              <a:latin typeface="Arial"/>
+            </a:endParaRPr>
           </a:p>
         </p:txBody>
       </p:sp>

</xml_diff>